<commit_message>
KP4: deck review fixes across modules 1-3; slide figures added
Co-Authored-By: Claude Opus 5.5 <noreply@anthropic.com>
</commit_message>
<xml_diff>
--- a/10-Knowledge-Products/KP4-DSD/videos/module_1/en/decks/KP4_M1_1.1_Deck_v0.1.pptx
+++ b/10-Knowledge-Products/KP4-DSD/videos/module_1/en/decks/KP4_M1_1.1_Deck_v0.1.pptx
@@ -1389,7 +1389,7 @@
           <a:p/>
           <a:p>
             <a:r>
-              <a:t>Slide specification: The three places in the same words as slide 3, so the viewer can match them. Text boxes only.</a:t>
+              <a:t>Slide specification: Figure F2, its slide variant (figures/slides/F2_three-places.png, drawn by the figure's own program in slide mode): the three places on the way from the request to the running service, each with the loss of the worked example under it, in the same words as slide 3; boxes, arrows and words only, no imagery and no person on screen. The rows are its text equivalent. Calibration item: a drawn figure under ITU's text-only rule.</a:t>
             </a:r>
           </a:p>
         </p:txBody>
@@ -13535,262 +13535,33 @@
           </a:p>
         </p:txBody>
       </p:sp>
-      <p:sp>
-        <p:nvSpPr>
-          <p:cNvPr id="4" name="TextBox 3"/>
-          <p:cNvSpPr txBox="1"/>
+      <p:pic>
+        <p:nvPicPr>
+          <p:cNvPr id="4" name="kp4-figure F2" descr="F2_three-places.png"/>
+          <p:cNvPicPr>
+            <a:picLocks noChangeAspect="1"/>
+          </p:cNvPicPr>
           <p:nvPr/>
-        </p:nvSpPr>
-        <p:spPr>
-          <a:xfrm>
-            <a:off x="658368" y="1463040"/>
-            <a:ext cx="10984687" cy="1524000"/>
+        </p:nvPicPr>
+        <p:blipFill>
+          <a:blip r:embed="rId2"/>
+          <a:stretch>
+            <a:fillRect/>
+          </a:stretch>
+        </p:blipFill>
+        <p:spPr>
+          <a:xfrm>
+            <a:off x="1844824" y="1280160"/>
+            <a:ext cx="8508446" cy="5074920"/>
           </a:xfrm>
           <a:prstGeom prst="rect">
             <a:avLst/>
           </a:prstGeom>
-          <a:noFill/>
-        </p:spPr>
-        <p:txBody>
-          <a:bodyPr wrap="square">
-            <a:spAutoFit/>
-          </a:bodyPr>
-          <a:lstStyle/>
-          <a:p>
-            <a:pPr>
-              <a:spcAft>
-                <a:spcPts val="300"/>
-              </a:spcAft>
-            </a:pPr>
-            <a:r>
-              <a:rPr sz="1900" b="1" i="0">
-                <a:solidFill>
-                  <a:srgbClr val="1A1A1A"/>
-                </a:solidFill>
-                <a:latin typeface="Arial"/>
-              </a:rPr>
-              <a:t>May MoEYS read PHEQA's register? Never decided.</a:t>
-            </a:r>
-          </a:p>
-          <a:p>
-            <a:pPr>
-              <a:spcAft>
-                <a:spcPts val="300"/>
-              </a:spcAft>
-            </a:pPr>
-            <a:r>
-              <a:rPr sz="1550" b="0" i="0">
-                <a:solidFill>
-                  <a:srgbClr val="595959"/>
-                </a:solidFill>
-                <a:latin typeface="Arial"/>
-              </a:rPr>
-              <a:t>A question nobody decided.</a:t>
-            </a:r>
-          </a:p>
-        </p:txBody>
-      </p:sp>
-      <p:sp>
-        <p:nvSpPr>
-          <p:cNvPr id="5" name="Rectangle 4"/>
-          <p:cNvSpPr/>
-          <p:nvPr/>
-        </p:nvSpPr>
-        <p:spPr>
-          <a:xfrm>
-            <a:off x="621792" y="2991612"/>
-            <a:ext cx="10881360" cy="12700"/>
-          </a:xfrm>
-          <a:prstGeom prst="rect">
-            <a:avLst/>
-          </a:prstGeom>
-          <a:solidFill>
-            <a:srgbClr val="DDECF4"/>
-          </a:solidFill>
-          <a:ln>
-            <a:noFill/>
-          </a:ln>
-          <a:effectLst/>
-        </p:spPr>
-        <p:style>
-          <a:lnRef idx="1">
-            <a:schemeClr val="accent1"/>
-          </a:lnRef>
-          <a:fillRef idx="3">
-            <a:schemeClr val="accent1"/>
-          </a:fillRef>
-          <a:effectRef idx="2">
-            <a:schemeClr val="accent1"/>
-          </a:effectRef>
-          <a:fontRef idx="minor">
-            <a:schemeClr val="lt1"/>
-          </a:fontRef>
-        </p:style>
-        <p:txBody>
-          <a:bodyPr rtlCol="0" anchor="ctr"/>
-          <a:lstStyle/>
-          <a:p>
-            <a:pPr algn="ctr"/>
-          </a:p>
-        </p:txBody>
-      </p:sp>
-      <p:sp>
-        <p:nvSpPr>
-          <p:cNvPr id="6" name="TextBox 5"/>
-          <p:cNvSpPr txBox="1"/>
-          <p:nvPr/>
-        </p:nvSpPr>
-        <p:spPr>
-          <a:xfrm>
-            <a:off x="658368" y="3032760"/>
-            <a:ext cx="10984687" cy="1524000"/>
-          </a:xfrm>
-          <a:prstGeom prst="rect">
-            <a:avLst/>
-          </a:prstGeom>
-          <a:noFill/>
-        </p:spPr>
-        <p:txBody>
-          <a:bodyPr wrap="square">
-            <a:spAutoFit/>
-          </a:bodyPr>
-          <a:lstStyle/>
-          <a:p>
-            <a:pPr>
-              <a:spcAft>
-                <a:spcPts val="300"/>
-              </a:spcAft>
-            </a:pPr>
-            <a:r>
-              <a:rPr sz="1900" b="1" i="0">
-                <a:solidFill>
-                  <a:srgbClr val="1A1A1A"/>
-                </a:solidFill>
-                <a:latin typeface="Arial"/>
-              </a:rPr>
-              <a:t>PHEQA's number INS-00217 never reached MoEYS.</a:t>
-            </a:r>
-          </a:p>
-          <a:p>
-            <a:pPr>
-              <a:spcAft>
-                <a:spcPts val="300"/>
-              </a:spcAft>
-            </a:pPr>
-            <a:r>
-              <a:rPr sz="1550" b="0" i="0">
-                <a:solidFill>
-                  <a:srgbClr val="595959"/>
-                </a:solidFill>
-                <a:latin typeface="Arial"/>
-              </a:rPr>
-              <a:t>An answer nobody passed on.</a:t>
-            </a:r>
-          </a:p>
-        </p:txBody>
-      </p:sp>
-      <p:sp>
-        <p:nvSpPr>
-          <p:cNvPr id="7" name="Rectangle 6"/>
-          <p:cNvSpPr/>
-          <p:nvPr/>
-        </p:nvSpPr>
-        <p:spPr>
-          <a:xfrm>
-            <a:off x="621792" y="4561332"/>
-            <a:ext cx="10881360" cy="12700"/>
-          </a:xfrm>
-          <a:prstGeom prst="rect">
-            <a:avLst/>
-          </a:prstGeom>
-          <a:solidFill>
-            <a:srgbClr val="DDECF4"/>
-          </a:solidFill>
-          <a:ln>
-            <a:noFill/>
-          </a:ln>
-          <a:effectLst/>
-        </p:spPr>
-        <p:style>
-          <a:lnRef idx="1">
-            <a:schemeClr val="accent1"/>
-          </a:lnRef>
-          <a:fillRef idx="3">
-            <a:schemeClr val="accent1"/>
-          </a:fillRef>
-          <a:effectRef idx="2">
-            <a:schemeClr val="accent1"/>
-          </a:effectRef>
-          <a:fontRef idx="minor">
-            <a:schemeClr val="lt1"/>
-          </a:fontRef>
-        </p:style>
-        <p:txBody>
-          <a:bodyPr rtlCol="0" anchor="ctr"/>
-          <a:lstStyle/>
-          <a:p>
-            <a:pPr algn="ctr"/>
-          </a:p>
-        </p:txBody>
-      </p:sp>
-      <p:sp>
-        <p:nvSpPr>
-          <p:cNvPr id="8" name="TextBox 7"/>
-          <p:cNvSpPr txBox="1"/>
-          <p:nvPr/>
-        </p:nvSpPr>
-        <p:spPr>
-          <a:xfrm>
-            <a:off x="658368" y="4602480"/>
-            <a:ext cx="10984687" cy="1524000"/>
-          </a:xfrm>
-          <a:prstGeom prst="rect">
-            <a:avLst/>
-          </a:prstGeom>
-          <a:noFill/>
-        </p:spPr>
-        <p:txBody>
-          <a:bodyPr wrap="square">
-            <a:spAutoFit/>
-          </a:bodyPr>
-          <a:lstStyle/>
-          <a:p>
-            <a:pPr>
-              <a:spcAft>
-                <a:spcPts val="300"/>
-              </a:spcAft>
-            </a:pPr>
-            <a:r>
-              <a:rPr sz="1900" b="1" i="0">
-                <a:solidFill>
-                  <a:srgbClr val="1A1A1A"/>
-                </a:solidFill>
-                <a:latin typeface="Arial"/>
-              </a:rPr>
-              <a:t>A fact is entered once: written in the strategy, checked nowhere.</a:t>
-            </a:r>
-          </a:p>
-          <a:p>
-            <a:pPr>
-              <a:spcAft>
-                <a:spcPts val="300"/>
-              </a:spcAft>
-            </a:pPr>
-            <a:r>
-              <a:rPr sz="1550" b="0" i="0">
-                <a:solidFill>
-                  <a:srgbClr val="595959"/>
-                </a:solidFill>
-                <a:latin typeface="Arial"/>
-              </a:rPr>
-              <a:t>A rule nobody enforced.</a:t>
-            </a:r>
-          </a:p>
-        </p:txBody>
-      </p:sp>
-      <p:sp>
-        <p:nvSpPr>
-          <p:cNvPr id="9" name="TextBox 8"/>
+        </p:spPr>
+      </p:pic>
+      <p:sp>
+        <p:nvSpPr>
+          <p:cNvPr id="5" name="TextBox 4"/>
           <p:cNvSpPr txBox="1"/>
           <p:nvPr/>
         </p:nvSpPr>

</xml_diff>